<commit_message>
intégration preprocessing et correction dag d'inference.
</commit_message>
<xml_diff>
--- a/VulcaData.pptx
+++ b/VulcaData.pptx
@@ -792,8 +792,8 @@
         </p:nvSpPr>
         <p:spPr>
           <a:xfrm>
-            <a:off x="1143225" y="685800"/>
-            <a:ext cx="4572225" cy="3429000"/>
+            <a:off x="381000" y="685800"/>
+            <a:ext cx="6096000" cy="3429000"/>
           </a:xfrm>
           <a:custGeom>
             <a:avLst/>
@@ -16260,105 +16260,52 @@
       </p:grpSpPr>
       <p:sp>
         <p:nvSpPr>
-          <p:cNvPr id="129" name="Google Shape;129;p25"/>
-          <p:cNvSpPr/>
-          <p:nvPr/>
-        </p:nvSpPr>
-        <p:spPr>
-          <a:xfrm>
-            <a:off x="4572000" y="0"/>
-            <a:ext cx="4562431" cy="5130509"/>
-          </a:xfrm>
-          <a:custGeom>
-            <a:avLst/>
-            <a:gdLst/>
-            <a:ahLst/>
-            <a:cxnLst/>
-            <a:rect l="l" t="t" r="r" b="b"/>
-            <a:pathLst>
-              <a:path w="9554829" h="10633179" extrusionOk="0">
-                <a:moveTo>
-                  <a:pt x="0" y="0"/>
-                </a:moveTo>
-                <a:lnTo>
-                  <a:pt x="9554829" y="0"/>
-                </a:lnTo>
-                <a:lnTo>
-                  <a:pt x="9554829" y="10633180"/>
-                </a:lnTo>
-                <a:lnTo>
-                  <a:pt x="0" y="10633180"/>
-                </a:lnTo>
-                <a:lnTo>
-                  <a:pt x="0" y="0"/>
-                </a:lnTo>
-                <a:close/>
-              </a:path>
-            </a:pathLst>
-          </a:custGeom>
-          <a:blipFill rotWithShape="1">
-            <a:blip r:embed="rId3">
-              <a:alphaModFix amt="25000"/>
-            </a:blip>
-            <a:stretch>
-              <a:fillRect l="-36050" r="-30974"/>
-            </a:stretch>
-          </a:blipFill>
-          <a:ln>
-            <a:noFill/>
-          </a:ln>
-        </p:spPr>
-      </p:sp>
-      <p:sp>
-        <p:nvSpPr>
-          <p:cNvPr id="130" name="Google Shape;130;p25"/>
+          <p:cNvPr id="3" name="Rectangle 2">
+            <a:extLst>
+              <a:ext uri="{FF2B5EF4-FFF2-40B4-BE49-F238E27FC236}">
+                <a16:creationId xmlns:a16="http://schemas.microsoft.com/office/drawing/2014/main" id="{84D159F3-61F0-C914-7BE1-248FDE119245}"/>
+              </a:ext>
+            </a:extLst>
+          </p:cNvPr>
           <p:cNvSpPr/>
           <p:nvPr/>
         </p:nvSpPr>
         <p:spPr>
           <a:xfrm>
             <a:off x="0" y="0"/>
-            <a:ext cx="4562431" cy="5130509"/>
+            <a:ext cx="9144000" cy="5143500"/>
           </a:xfrm>
-          <a:custGeom>
+          <a:prstGeom prst="rect">
             <a:avLst/>
-            <a:gdLst/>
-            <a:ahLst/>
-            <a:cxnLst/>
-            <a:rect l="l" t="t" r="r" b="b"/>
-            <a:pathLst>
-              <a:path w="9554829" h="10633179" extrusionOk="0">
-                <a:moveTo>
-                  <a:pt x="0" y="0"/>
-                </a:moveTo>
-                <a:lnTo>
-                  <a:pt x="9554829" y="0"/>
-                </a:lnTo>
-                <a:lnTo>
-                  <a:pt x="9554829" y="10633180"/>
-                </a:lnTo>
-                <a:lnTo>
-                  <a:pt x="0" y="10633180"/>
-                </a:lnTo>
-                <a:lnTo>
-                  <a:pt x="0" y="0"/>
-                </a:lnTo>
-                <a:close/>
-              </a:path>
-            </a:pathLst>
-          </a:custGeom>
-          <a:blipFill rotWithShape="1">
-            <a:blip r:embed="rId3">
-              <a:alphaModFix amt="25000"/>
-            </a:blip>
-            <a:stretch>
-              <a:fillRect l="-36050" r="-30974"/>
-            </a:stretch>
-          </a:blipFill>
-          <a:ln>
-            <a:noFill/>
-          </a:ln>
+          </a:prstGeom>
+          <a:solidFill>
+            <a:schemeClr val="bg1"/>
+          </a:solidFill>
         </p:spPr>
+        <p:style>
+          <a:lnRef idx="2">
+            <a:schemeClr val="accent1">
+              <a:shade val="15000"/>
+            </a:schemeClr>
+          </a:lnRef>
+          <a:fillRef idx="1">
+            <a:schemeClr val="accent1"/>
+          </a:fillRef>
+          <a:effectRef idx="0">
+            <a:schemeClr val="accent1"/>
+          </a:effectRef>
+          <a:fontRef idx="minor">
+            <a:schemeClr val="lt1"/>
+          </a:fontRef>
+        </p:style>
+        <p:txBody>
+          <a:bodyPr rtlCol="0" anchor="ctr"/>
+          <a:lstStyle/>
+          <a:p>
+            <a:pPr algn="ctr"/>
+            <a:endParaRPr lang="fr-FR"/>
+          </a:p>
+        </p:txBody>
       </p:sp>
       <p:sp>
         <p:nvSpPr>
@@ -16399,7 +16346,7 @@
             </a:pathLst>
           </a:custGeom>
           <a:blipFill rotWithShape="1">
-            <a:blip r:embed="rId4">
+            <a:blip r:embed="rId3">
               <a:alphaModFix/>
             </a:blip>
             <a:stretch>

</xml_diff>